<commit_message>
update poster, finished MLP version
</commit_message>
<xml_diff>
--- a/4420 poster.pptx
+++ b/4420 poster.pptx
@@ -3339,26 +3339,26 @@
         </p:nvSpPr>
         <p:spPr>
           <a:xfrm>
-            <a:off x="3618571" y="133815"/>
+            <a:off x="3618571" y="26308"/>
             <a:ext cx="4954858" cy="706437"/>
           </a:xfrm>
         </p:spPr>
         <p:txBody>
           <a:bodyPr>
-            <a:normAutofit fontScale="90000"/>
+            <a:normAutofit/>
           </a:bodyPr>
           <a:lstStyle/>
           <a:p>
             <a:r>
-              <a:rPr lang="en-US" altLang="zh-CN" sz="1800" b="1" kern="100" dirty="0">
+              <a:rPr lang="en-US" altLang="zh-CN" sz="1400" b="1" kern="100" dirty="0">
                 <a:effectLst/>
                 <a:latin typeface="Times New Roman" panose="02020603050405020304" pitchFamily="18" charset="0"/>
                 <a:ea typeface="DengXian" panose="02010600030101010101" pitchFamily="2" charset="-122"/>
                 <a:cs typeface="Times New Roman" panose="02020603050405020304" pitchFamily="18" charset="0"/>
               </a:rPr>
-              <a:t>Predicting Building-Level Flood Risk by Analysis Comparison of Multi-Layer Perceptron and Bayesian Logistic Regression</a:t>
-            </a:r>
-            <a:endParaRPr kumimoji="1" lang="zh-CN" altLang="en-US" dirty="0"/>
+              <a:t>Predicting Building - Level Flood Risk by Analysis Comparison of Multi-Layer Perceptron and Bayesian Logistic Regression</a:t>
+            </a:r>
+            <a:endParaRPr kumimoji="1" lang="zh-CN" altLang="en-US" sz="1400" dirty="0"/>
           </a:p>
         </p:txBody>
       </p:sp>
@@ -3392,6 +3392,1584 @@
           </a:prstGeom>
         </p:spPr>
       </p:pic>
+      <p:pic>
+        <p:nvPicPr>
+          <p:cNvPr id="7" name="图片 6">
+            <a:extLst>
+              <a:ext uri="{FF2B5EF4-FFF2-40B4-BE49-F238E27FC236}">
+                <a16:creationId xmlns:a16="http://schemas.microsoft.com/office/drawing/2014/main" id="{E72EC5B1-C59B-E3BC-C34E-B8CE9278270D}"/>
+              </a:ext>
+            </a:extLst>
+          </p:cNvPr>
+          <p:cNvPicPr>
+            <a:picLocks noChangeAspect="1"/>
+          </p:cNvPicPr>
+          <p:nvPr/>
+        </p:nvPicPr>
+        <p:blipFill>
+          <a:blip r:embed="rId3"/>
+          <a:stretch>
+            <a:fillRect/>
+          </a:stretch>
+        </p:blipFill>
+        <p:spPr>
+          <a:xfrm>
+            <a:off x="51986" y="992461"/>
+            <a:ext cx="12088028" cy="244448"/>
+          </a:xfrm>
+          <a:prstGeom prst="rect">
+            <a:avLst/>
+          </a:prstGeom>
+        </p:spPr>
+      </p:pic>
+      <p:sp>
+        <p:nvSpPr>
+          <p:cNvPr id="8" name="文本框 7">
+            <a:extLst>
+              <a:ext uri="{FF2B5EF4-FFF2-40B4-BE49-F238E27FC236}">
+                <a16:creationId xmlns:a16="http://schemas.microsoft.com/office/drawing/2014/main" id="{12C45D58-8CFE-78D3-4B53-C071C2EAD4EA}"/>
+              </a:ext>
+            </a:extLst>
+          </p:cNvPr>
+          <p:cNvSpPr txBox="1"/>
+          <p:nvPr/>
+        </p:nvSpPr>
+        <p:spPr>
+          <a:xfrm>
+            <a:off x="3648307" y="746240"/>
+            <a:ext cx="4895385" cy="246221"/>
+          </a:xfrm>
+          <a:prstGeom prst="rect">
+            <a:avLst/>
+          </a:prstGeom>
+          <a:noFill/>
+        </p:spPr>
+        <p:txBody>
+          <a:bodyPr wrap="square" rtlCol="0">
+            <a:spAutoFit/>
+          </a:bodyPr>
+          <a:lstStyle/>
+          <a:p>
+            <a:pPr algn="ctr"/>
+            <a:r>
+              <a:rPr kumimoji="1" lang="en-US" altLang="zh-CN" sz="1000" dirty="0"/>
+              <a:t>DS4420 Project by: Lang Shao, </a:t>
+            </a:r>
+            <a:r>
+              <a:rPr kumimoji="1" lang="en-US" altLang="zh-CN" sz="1000" dirty="0" err="1"/>
+              <a:t>Jiada</a:t>
+            </a:r>
+            <a:r>
+              <a:rPr kumimoji="1" lang="en-US" altLang="zh-CN" sz="1000" dirty="0"/>
+              <a:t> Li</a:t>
+            </a:r>
+            <a:endParaRPr kumimoji="1" lang="zh-CN" altLang="en-US" sz="1000" dirty="0"/>
+          </a:p>
+        </p:txBody>
+      </p:sp>
+      <p:sp>
+        <p:nvSpPr>
+          <p:cNvPr id="9" name="文本框 8">
+            <a:extLst>
+              <a:ext uri="{FF2B5EF4-FFF2-40B4-BE49-F238E27FC236}">
+                <a16:creationId xmlns:a16="http://schemas.microsoft.com/office/drawing/2014/main" id="{8AD4B41E-5B92-21CC-5E2C-BBFBAAA38482}"/>
+              </a:ext>
+            </a:extLst>
+          </p:cNvPr>
+          <p:cNvSpPr txBox="1"/>
+          <p:nvPr/>
+        </p:nvSpPr>
+        <p:spPr>
+          <a:xfrm>
+            <a:off x="293525" y="1235484"/>
+            <a:ext cx="2798956" cy="276999"/>
+          </a:xfrm>
+          <a:prstGeom prst="rect">
+            <a:avLst/>
+          </a:prstGeom>
+          <a:noFill/>
+        </p:spPr>
+        <p:txBody>
+          <a:bodyPr wrap="square" rtlCol="0">
+            <a:spAutoFit/>
+          </a:bodyPr>
+          <a:lstStyle/>
+          <a:p>
+            <a:r>
+              <a:rPr lang="en-US" altLang="zh-CN" sz="1200" b="1" dirty="0"/>
+              <a:t>Introduction &amp; Problem </a:t>
+            </a:r>
+            <a:endParaRPr kumimoji="1" lang="zh-CN" altLang="en-US" sz="1200" b="1" dirty="0"/>
+          </a:p>
+        </p:txBody>
+      </p:sp>
+      <p:sp>
+        <p:nvSpPr>
+          <p:cNvPr id="11" name="文本框 10">
+            <a:extLst>
+              <a:ext uri="{FF2B5EF4-FFF2-40B4-BE49-F238E27FC236}">
+                <a16:creationId xmlns:a16="http://schemas.microsoft.com/office/drawing/2014/main" id="{77E89F91-FEA9-296C-E324-81D32D5F1AC4}"/>
+              </a:ext>
+            </a:extLst>
+          </p:cNvPr>
+          <p:cNvSpPr txBox="1"/>
+          <p:nvPr/>
+        </p:nvSpPr>
+        <p:spPr>
+          <a:xfrm>
+            <a:off x="301083" y="1304861"/>
+            <a:ext cx="3317488" cy="1919949"/>
+          </a:xfrm>
+          <a:prstGeom prst="rect">
+            <a:avLst/>
+          </a:prstGeom>
+          <a:noFill/>
+        </p:spPr>
+        <p:txBody>
+          <a:bodyPr wrap="square">
+            <a:spAutoFit/>
+          </a:bodyPr>
+          <a:lstStyle/>
+          <a:p>
+            <a:pPr>
+              <a:lnSpc>
+                <a:spcPct val="150000"/>
+              </a:lnSpc>
+            </a:pPr>
+            <a:endParaRPr lang="en-US" altLang="zh-CN" sz="800" dirty="0">
+              <a:effectLst/>
+            </a:endParaRPr>
+          </a:p>
+          <a:p>
+            <a:pPr>
+              <a:lnSpc>
+                <a:spcPct val="150000"/>
+              </a:lnSpc>
+              <a:buFont typeface="Arial" panose="020B0604020202020204" pitchFamily="34" charset="0"/>
+              <a:buChar char="•"/>
+            </a:pPr>
+            <a:r>
+              <a:rPr lang="en-US" altLang="zh-CN" sz="800" b="1" dirty="0">
+                <a:effectLst/>
+              </a:rPr>
+              <a:t>The Problem:</a:t>
+            </a:r>
+            <a:r>
+              <a:rPr lang="en-US" altLang="zh-CN" sz="800" dirty="0">
+                <a:effectLst/>
+              </a:rPr>
+              <a:t> Current FEMA Flood Insurance Rate Maps (FIRMs) rely on macro-level topographic data, largely ignoring specific physical characteristics of individual structures.</a:t>
+            </a:r>
+          </a:p>
+          <a:p>
+            <a:pPr>
+              <a:lnSpc>
+                <a:spcPct val="150000"/>
+              </a:lnSpc>
+              <a:buFont typeface="Arial" panose="020B0604020202020204" pitchFamily="34" charset="0"/>
+              <a:buChar char="•"/>
+            </a:pPr>
+            <a:r>
+              <a:rPr lang="en-US" altLang="zh-CN" sz="800" b="1" dirty="0">
+                <a:effectLst/>
+              </a:rPr>
+              <a:t>The Consequence:</a:t>
+            </a:r>
+            <a:r>
+              <a:rPr lang="en-US" altLang="zh-CN" sz="800" dirty="0">
+                <a:effectLst/>
+              </a:rPr>
+              <a:t> Two houses in the exact same flood zone can have drastically different true vulnerabilities depending on micro-level factors (</a:t>
+            </a:r>
+            <a:r>
+              <a:rPr lang="en-US" altLang="zh-CN" sz="800" dirty="0"/>
+              <a:t>like</a:t>
+            </a:r>
+            <a:r>
+              <a:rPr lang="en-US" altLang="zh-CN" sz="800" dirty="0">
+                <a:effectLst/>
+              </a:rPr>
+              <a:t> foundation height).</a:t>
+            </a:r>
+          </a:p>
+          <a:p>
+            <a:pPr>
+              <a:lnSpc>
+                <a:spcPct val="150000"/>
+              </a:lnSpc>
+              <a:buFont typeface="Arial" panose="020B0604020202020204" pitchFamily="34" charset="0"/>
+              <a:buChar char="•"/>
+            </a:pPr>
+            <a:r>
+              <a:rPr lang="en-US" altLang="zh-CN" sz="800" b="1" dirty="0">
+                <a:effectLst/>
+              </a:rPr>
+              <a:t>Our Objective:</a:t>
+            </a:r>
+            <a:r>
+              <a:rPr lang="en-US" altLang="zh-CN" sz="800" dirty="0">
+                <a:effectLst/>
+              </a:rPr>
+              <a:t> Leverage National Structure Inventory (NSI) data to model flood risk at the individual building level, shifting from geospatial area-mapping to structural vulnerability classification.</a:t>
+            </a:r>
+          </a:p>
+        </p:txBody>
+      </p:sp>
+      <p:sp>
+        <p:nvSpPr>
+          <p:cNvPr id="13" name="文本框 12">
+            <a:extLst>
+              <a:ext uri="{FF2B5EF4-FFF2-40B4-BE49-F238E27FC236}">
+                <a16:creationId xmlns:a16="http://schemas.microsoft.com/office/drawing/2014/main" id="{F120676D-2631-2C02-E7DD-639B1DC09EA2}"/>
+              </a:ext>
+            </a:extLst>
+          </p:cNvPr>
+          <p:cNvSpPr txBox="1"/>
+          <p:nvPr/>
+        </p:nvSpPr>
+        <p:spPr>
+          <a:xfrm>
+            <a:off x="301083" y="3330391"/>
+            <a:ext cx="1243237" cy="276999"/>
+          </a:xfrm>
+          <a:prstGeom prst="rect">
+            <a:avLst/>
+          </a:prstGeom>
+          <a:noFill/>
+        </p:spPr>
+        <p:txBody>
+          <a:bodyPr wrap="square">
+            <a:spAutoFit/>
+          </a:bodyPr>
+          <a:lstStyle/>
+          <a:p>
+            <a:r>
+              <a:rPr lang="en-US" altLang="zh-CN" sz="1200" b="1" dirty="0"/>
+              <a:t>Data Overview</a:t>
+            </a:r>
+            <a:endParaRPr lang="zh-CN" altLang="en-US" sz="1200" b="1" dirty="0"/>
+          </a:p>
+        </p:txBody>
+      </p:sp>
+      <p:sp>
+        <p:nvSpPr>
+          <p:cNvPr id="15" name="文本框 14">
+            <a:extLst>
+              <a:ext uri="{FF2B5EF4-FFF2-40B4-BE49-F238E27FC236}">
+                <a16:creationId xmlns:a16="http://schemas.microsoft.com/office/drawing/2014/main" id="{33326DDC-C2B8-83B4-9A73-31CCDEE5430F}"/>
+              </a:ext>
+            </a:extLst>
+          </p:cNvPr>
+          <p:cNvSpPr txBox="1"/>
+          <p:nvPr/>
+        </p:nvSpPr>
+        <p:spPr>
+          <a:xfrm>
+            <a:off x="293525" y="3607390"/>
+            <a:ext cx="2259237" cy="1735540"/>
+          </a:xfrm>
+          <a:prstGeom prst="rect">
+            <a:avLst/>
+          </a:prstGeom>
+          <a:noFill/>
+        </p:spPr>
+        <p:txBody>
+          <a:bodyPr wrap="square">
+            <a:spAutoFit/>
+          </a:bodyPr>
+          <a:lstStyle/>
+          <a:p>
+            <a:pPr>
+              <a:lnSpc>
+                <a:spcPct val="150000"/>
+              </a:lnSpc>
+            </a:pPr>
+            <a:r>
+              <a:rPr lang="en-US" altLang="zh-CN" sz="800" b="1" dirty="0"/>
+              <a:t>Dataset:</a:t>
+            </a:r>
+            <a:r>
+              <a:rPr lang="en-US" altLang="zh-CN" sz="800" dirty="0"/>
+              <a:t> National Structure Inventory (NSI).</a:t>
+            </a:r>
+          </a:p>
+          <a:p>
+            <a:pPr>
+              <a:lnSpc>
+                <a:spcPct val="150000"/>
+              </a:lnSpc>
+            </a:pPr>
+            <a:r>
+              <a:rPr lang="en-US" altLang="zh-CN" sz="800" dirty="0">
+                <a:highlight>
+                  <a:srgbClr val="FFFF00"/>
+                </a:highlight>
+              </a:rPr>
+              <a:t>FROM</a:t>
+            </a:r>
+            <a:r>
+              <a:rPr lang="zh-CN" altLang="en-US" sz="800" dirty="0">
+                <a:highlight>
+                  <a:srgbClr val="FFFF00"/>
+                </a:highlight>
+              </a:rPr>
+              <a:t> </a:t>
+            </a:r>
+            <a:r>
+              <a:rPr lang="en-US" altLang="zh-CN" sz="800" dirty="0">
+                <a:highlight>
+                  <a:srgbClr val="FFFF00"/>
+                </a:highlight>
+              </a:rPr>
+              <a:t>GPKG TO CSV!</a:t>
+            </a:r>
+          </a:p>
+          <a:p>
+            <a:pPr>
+              <a:lnSpc>
+                <a:spcPct val="150000"/>
+              </a:lnSpc>
+            </a:pPr>
+            <a:r>
+              <a:rPr lang="en-US" altLang="zh-CN" sz="800" b="1" dirty="0"/>
+              <a:t>Target Variable:</a:t>
+            </a:r>
+            <a:r>
+              <a:rPr lang="en-US" altLang="zh-CN" sz="800" dirty="0"/>
+              <a:t> FEMA FIRM Zones.</a:t>
+            </a:r>
+          </a:p>
+          <a:p>
+            <a:pPr>
+              <a:lnSpc>
+                <a:spcPct val="150000"/>
+              </a:lnSpc>
+              <a:buFont typeface="Arial" panose="020B0604020202020204" pitchFamily="34" charset="0"/>
+              <a:buChar char="•"/>
+            </a:pPr>
+            <a:r>
+              <a:rPr lang="en-US" altLang="zh-CN" sz="800" b="1" dirty="0"/>
+              <a:t>High-Risk (1):</a:t>
+            </a:r>
+            <a:r>
+              <a:rPr lang="en-US" altLang="zh-CN" sz="800" dirty="0"/>
+              <a:t> VE, AE, A, AO, AH.</a:t>
+            </a:r>
+          </a:p>
+          <a:p>
+            <a:pPr>
+              <a:lnSpc>
+                <a:spcPct val="150000"/>
+              </a:lnSpc>
+              <a:buFont typeface="Arial" panose="020B0604020202020204" pitchFamily="34" charset="0"/>
+              <a:buChar char="•"/>
+            </a:pPr>
+            <a:r>
+              <a:rPr lang="en-US" altLang="zh-CN" sz="800" b="1" dirty="0"/>
+              <a:t>Low-Risk (0):</a:t>
+            </a:r>
+            <a:r>
+              <a:rPr lang="en-US" altLang="zh-CN" sz="800" dirty="0"/>
+              <a:t> Area X.</a:t>
+            </a:r>
+          </a:p>
+          <a:p>
+            <a:pPr>
+              <a:lnSpc>
+                <a:spcPct val="150000"/>
+              </a:lnSpc>
+            </a:pPr>
+            <a:r>
+              <a:rPr lang="en-US" altLang="zh-CN" sz="800" b="1" dirty="0"/>
+              <a:t>Key Features:</a:t>
+            </a:r>
+            <a:r>
+              <a:rPr lang="en-US" altLang="zh-CN" sz="800" dirty="0"/>
+              <a:t> Ground elevation (</a:t>
+            </a:r>
+            <a:r>
+              <a:rPr lang="en-US" altLang="zh-CN" sz="800" dirty="0" err="1"/>
+              <a:t>ground_elv</a:t>
+            </a:r>
+            <a:r>
+              <a:rPr lang="en-US" altLang="zh-CN" sz="800" dirty="0"/>
+              <a:t>), foundation height (</a:t>
+            </a:r>
+            <a:r>
+              <a:rPr lang="en-US" altLang="zh-CN" sz="800" dirty="0" err="1"/>
+              <a:t>found_ht</a:t>
+            </a:r>
+            <a:r>
+              <a:rPr lang="en-US" altLang="zh-CN" sz="800" dirty="0"/>
+              <a:t>), structural value, year built, square footage, number of stories, building type, and foundation type.</a:t>
+            </a:r>
+          </a:p>
+        </p:txBody>
+      </p:sp>
+      <p:sp>
+        <p:nvSpPr>
+          <p:cNvPr id="17" name="文本框 16">
+            <a:extLst>
+              <a:ext uri="{FF2B5EF4-FFF2-40B4-BE49-F238E27FC236}">
+                <a16:creationId xmlns:a16="http://schemas.microsoft.com/office/drawing/2014/main" id="{63E8D7D8-C28F-278A-64AA-21B736E523A6}"/>
+              </a:ext>
+            </a:extLst>
+          </p:cNvPr>
+          <p:cNvSpPr txBox="1"/>
+          <p:nvPr/>
+        </p:nvSpPr>
+        <p:spPr>
+          <a:xfrm>
+            <a:off x="22249" y="682911"/>
+            <a:ext cx="1400895" cy="553998"/>
+          </a:xfrm>
+          <a:prstGeom prst="rect">
+            <a:avLst/>
+          </a:prstGeom>
+          <a:noFill/>
+        </p:spPr>
+        <p:txBody>
+          <a:bodyPr wrap="square">
+            <a:spAutoFit/>
+          </a:bodyPr>
+          <a:lstStyle/>
+          <a:p>
+            <a:r>
+              <a:rPr lang="en-US" altLang="zh-CN" sz="3000" dirty="0"/>
+              <a:t>🌊</a:t>
+            </a:r>
+            <a:r>
+              <a:rPr lang="zh-CN" altLang="en-US" sz="3000" dirty="0"/>
+              <a:t> </a:t>
+            </a:r>
+            <a:r>
+              <a:rPr lang="en-US" altLang="zh-CN" sz="3000" dirty="0"/>
+              <a:t>☠️</a:t>
+            </a:r>
+          </a:p>
+        </p:txBody>
+      </p:sp>
+      <p:sp>
+        <p:nvSpPr>
+          <p:cNvPr id="19" name="文本框 18">
+            <a:extLst>
+              <a:ext uri="{FF2B5EF4-FFF2-40B4-BE49-F238E27FC236}">
+                <a16:creationId xmlns:a16="http://schemas.microsoft.com/office/drawing/2014/main" id="{98ECACF9-36C1-9586-0BE9-3B9626DF4018}"/>
+              </a:ext>
+            </a:extLst>
+          </p:cNvPr>
+          <p:cNvSpPr txBox="1"/>
+          <p:nvPr/>
+        </p:nvSpPr>
+        <p:spPr>
+          <a:xfrm>
+            <a:off x="4003411" y="1235484"/>
+            <a:ext cx="1788160" cy="276999"/>
+          </a:xfrm>
+          <a:prstGeom prst="rect">
+            <a:avLst/>
+          </a:prstGeom>
+          <a:noFill/>
+        </p:spPr>
+        <p:txBody>
+          <a:bodyPr wrap="square">
+            <a:spAutoFit/>
+          </a:bodyPr>
+          <a:lstStyle/>
+          <a:p>
+            <a:r>
+              <a:rPr lang="en-US" altLang="zh-CN" sz="1200" b="1" dirty="0"/>
+              <a:t>Methodology</a:t>
+            </a:r>
+            <a:endParaRPr lang="zh-CN" altLang="en-US" sz="1200" b="1" dirty="0"/>
+          </a:p>
+        </p:txBody>
+      </p:sp>
+      <p:sp>
+        <p:nvSpPr>
+          <p:cNvPr id="21" name="文本框 20">
+            <a:extLst>
+              <a:ext uri="{FF2B5EF4-FFF2-40B4-BE49-F238E27FC236}">
+                <a16:creationId xmlns:a16="http://schemas.microsoft.com/office/drawing/2014/main" id="{5C499FB7-B94D-8C9F-9A81-86398ACB23C6}"/>
+              </a:ext>
+            </a:extLst>
+          </p:cNvPr>
+          <p:cNvSpPr txBox="1"/>
+          <p:nvPr/>
+        </p:nvSpPr>
+        <p:spPr>
+          <a:xfrm>
+            <a:off x="4003411" y="1523547"/>
+            <a:ext cx="4104269" cy="1365951"/>
+          </a:xfrm>
+          <a:prstGeom prst="rect">
+            <a:avLst/>
+          </a:prstGeom>
+          <a:noFill/>
+        </p:spPr>
+        <p:txBody>
+          <a:bodyPr wrap="square">
+            <a:spAutoFit/>
+          </a:bodyPr>
+          <a:lstStyle/>
+          <a:p>
+            <a:pPr>
+              <a:lnSpc>
+                <a:spcPct val="150000"/>
+              </a:lnSpc>
+            </a:pPr>
+            <a:r>
+              <a:rPr lang="en-US" altLang="zh-CN" sz="800" b="1" dirty="0">
+                <a:effectLst/>
+              </a:rPr>
+              <a:t>1. Custom MLP (By Lang)</a:t>
+            </a:r>
+            <a:endParaRPr lang="zh-CN" altLang="en-US" sz="800" dirty="0">
+              <a:effectLst/>
+            </a:endParaRPr>
+          </a:p>
+          <a:p>
+            <a:pPr>
+              <a:lnSpc>
+                <a:spcPct val="150000"/>
+              </a:lnSpc>
+              <a:buFont typeface="Arial" panose="020B0604020202020204" pitchFamily="34" charset="0"/>
+              <a:buChar char="•"/>
+            </a:pPr>
+            <a:r>
+              <a:rPr lang="en-US" altLang="zh-CN" sz="800" b="1" dirty="0">
+                <a:effectLst/>
+              </a:rPr>
+              <a:t>Implementation:</a:t>
+            </a:r>
+            <a:r>
+              <a:rPr lang="en-US" altLang="zh-CN" sz="800" dirty="0">
+                <a:effectLst/>
+              </a:rPr>
+              <a:t> </a:t>
+            </a:r>
+            <a:r>
+              <a:rPr lang="en-US" altLang="zh-CN" sz="800" dirty="0"/>
+              <a:t>It was b</a:t>
+            </a:r>
+            <a:r>
+              <a:rPr lang="en-US" altLang="zh-CN" sz="800" dirty="0">
+                <a:effectLst/>
+              </a:rPr>
+              <a:t>uilt manually by using Python and NumPy matrix operations </a:t>
+            </a:r>
+            <a:r>
+              <a:rPr lang="en-US" altLang="zh-CN" sz="800" b="1" dirty="0">
+                <a:effectLst/>
+              </a:rPr>
+              <a:t>Architecture:</a:t>
+            </a:r>
+            <a:r>
+              <a:rPr lang="en-US" altLang="zh-CN" sz="800" dirty="0">
+                <a:effectLst/>
+              </a:rPr>
+              <a:t> * Input Layer: d dimensional feature space.</a:t>
+            </a:r>
+          </a:p>
+          <a:p>
+            <a:pPr marL="742950" lvl="1" indent="-285750">
+              <a:lnSpc>
+                <a:spcPct val="150000"/>
+              </a:lnSpc>
+              <a:buFont typeface="Arial" panose="020B0604020202020204" pitchFamily="34" charset="0"/>
+              <a:buChar char="•"/>
+            </a:pPr>
+            <a:r>
+              <a:rPr lang="en-US" altLang="zh-CN" sz="800" dirty="0">
+                <a:effectLst/>
+              </a:rPr>
+              <a:t>Hidden Layer: 16 nodes with </a:t>
+            </a:r>
+            <a:r>
+              <a:rPr lang="en-US" altLang="zh-CN" sz="800" b="1" dirty="0" err="1">
+                <a:effectLst/>
+              </a:rPr>
+              <a:t>ReLU</a:t>
+            </a:r>
+            <a:r>
+              <a:rPr lang="en-US" altLang="zh-CN" sz="800" dirty="0">
+                <a:effectLst/>
+              </a:rPr>
+              <a:t> activation</a:t>
+            </a:r>
+          </a:p>
+          <a:p>
+            <a:pPr marL="742950" lvl="1" indent="-285750">
+              <a:lnSpc>
+                <a:spcPct val="150000"/>
+              </a:lnSpc>
+              <a:buFont typeface="Arial" panose="020B0604020202020204" pitchFamily="34" charset="0"/>
+              <a:buChar char="•"/>
+            </a:pPr>
+            <a:r>
+              <a:rPr lang="en-US" altLang="zh-CN" sz="800" dirty="0">
+                <a:effectLst/>
+              </a:rPr>
+              <a:t>Output Layer: 1 node with </a:t>
+            </a:r>
+            <a:r>
+              <a:rPr lang="en-US" altLang="zh-CN" sz="800" b="1" dirty="0">
+                <a:effectLst/>
+              </a:rPr>
+              <a:t>Sigmoid</a:t>
+            </a:r>
+            <a:r>
+              <a:rPr lang="en-US" altLang="zh-CN" sz="800" dirty="0">
+                <a:effectLst/>
+              </a:rPr>
+              <a:t> activation for probability mapping</a:t>
+            </a:r>
+          </a:p>
+          <a:p>
+            <a:pPr>
+              <a:lnSpc>
+                <a:spcPct val="150000"/>
+              </a:lnSpc>
+              <a:buFont typeface="Arial" panose="020B0604020202020204" pitchFamily="34" charset="0"/>
+              <a:buChar char="•"/>
+            </a:pPr>
+            <a:r>
+              <a:rPr lang="en-US" altLang="zh-CN" sz="800" b="1" dirty="0">
+                <a:effectLst/>
+              </a:rPr>
+              <a:t>Optimization:</a:t>
+            </a:r>
+            <a:r>
+              <a:rPr lang="en-US" altLang="zh-CN" sz="800" dirty="0">
+                <a:effectLst/>
+              </a:rPr>
+              <a:t> Full-batch Gradient Descent minimizing Binary Cross-Entropy (BCE) loss (eta=0.05, 2000 epochs) </a:t>
+            </a:r>
+            <a:r>
+              <a:rPr lang="en-US" altLang="zh-CN" sz="800" dirty="0"/>
+              <a:t>:</a:t>
+            </a:r>
+            <a:endParaRPr lang="en-US" altLang="zh-CN" sz="800" dirty="0">
+              <a:effectLst/>
+            </a:endParaRPr>
+          </a:p>
+        </p:txBody>
+      </p:sp>
+      <p:pic>
+        <p:nvPicPr>
+          <p:cNvPr id="22" name="图片 21" descr="图片包含 文本&#10;&#10;描述已自动生成">
+            <a:extLst>
+              <a:ext uri="{FF2B5EF4-FFF2-40B4-BE49-F238E27FC236}">
+                <a16:creationId xmlns:a16="http://schemas.microsoft.com/office/drawing/2014/main" id="{6FF8055B-8071-BB7B-8C34-B7E87569EC76}"/>
+              </a:ext>
+            </a:extLst>
+          </p:cNvPr>
+          <p:cNvPicPr>
+            <a:picLocks noChangeAspect="1"/>
+          </p:cNvPicPr>
+          <p:nvPr/>
+        </p:nvPicPr>
+        <p:blipFill>
+          <a:blip r:embed="rId4"/>
+          <a:stretch>
+            <a:fillRect/>
+          </a:stretch>
+        </p:blipFill>
+        <p:spPr>
+          <a:xfrm>
+            <a:off x="6722269" y="1945997"/>
+            <a:ext cx="940797" cy="364857"/>
+          </a:xfrm>
+          <a:prstGeom prst="rect">
+            <a:avLst/>
+          </a:prstGeom>
+        </p:spPr>
+      </p:pic>
+      <p:pic>
+        <p:nvPicPr>
+          <p:cNvPr id="23" name="图片 22" descr="图片包含 徽标&#10;&#10;描述已自动生成">
+            <a:extLst>
+              <a:ext uri="{FF2B5EF4-FFF2-40B4-BE49-F238E27FC236}">
+                <a16:creationId xmlns:a16="http://schemas.microsoft.com/office/drawing/2014/main" id="{068FE5D0-4ECF-0EF5-95B4-485F8A84D724}"/>
+              </a:ext>
+            </a:extLst>
+          </p:cNvPr>
+          <p:cNvPicPr>
+            <a:picLocks noChangeAspect="1"/>
+          </p:cNvPicPr>
+          <p:nvPr/>
+        </p:nvPicPr>
+        <p:blipFill>
+          <a:blip r:embed="rId5"/>
+          <a:stretch>
+            <a:fillRect/>
+          </a:stretch>
+        </p:blipFill>
+        <p:spPr>
+          <a:xfrm>
+            <a:off x="5233711" y="2650040"/>
+            <a:ext cx="1640650" cy="339784"/>
+          </a:xfrm>
+          <a:prstGeom prst="rect">
+            <a:avLst/>
+          </a:prstGeom>
+        </p:spPr>
+      </p:pic>
+      <p:sp>
+        <p:nvSpPr>
+          <p:cNvPr id="25" name="文本框 24">
+            <a:extLst>
+              <a:ext uri="{FF2B5EF4-FFF2-40B4-BE49-F238E27FC236}">
+                <a16:creationId xmlns:a16="http://schemas.microsoft.com/office/drawing/2014/main" id="{916D872A-CB86-577D-D260-E4710CC4B2CE}"/>
+              </a:ext>
+            </a:extLst>
+          </p:cNvPr>
+          <p:cNvSpPr txBox="1"/>
+          <p:nvPr/>
+        </p:nvSpPr>
+        <p:spPr>
+          <a:xfrm>
+            <a:off x="4003411" y="2928991"/>
+            <a:ext cx="6157912" cy="215444"/>
+          </a:xfrm>
+          <a:prstGeom prst="rect">
+            <a:avLst/>
+          </a:prstGeom>
+          <a:noFill/>
+        </p:spPr>
+        <p:txBody>
+          <a:bodyPr wrap="square">
+            <a:spAutoFit/>
+          </a:bodyPr>
+          <a:lstStyle/>
+          <a:p>
+            <a:r>
+              <a:rPr lang="en-US" altLang="zh-CN" sz="800" b="1" dirty="0"/>
+              <a:t>2. Bayesian Logistic Regression(By </a:t>
+            </a:r>
+            <a:r>
+              <a:rPr lang="en-US" altLang="zh-CN" sz="800" b="1" dirty="0" err="1"/>
+              <a:t>Jiada</a:t>
+            </a:r>
+            <a:r>
+              <a:rPr lang="en-US" altLang="zh-CN" sz="800" b="1" dirty="0"/>
+              <a:t>)</a:t>
+            </a:r>
+            <a:endParaRPr lang="zh-CN" altLang="en-US" sz="800" b="1" dirty="0"/>
+          </a:p>
+        </p:txBody>
+      </p:sp>
+      <p:sp>
+        <p:nvSpPr>
+          <p:cNvPr id="27" name="文本框 26">
+            <a:extLst>
+              <a:ext uri="{FF2B5EF4-FFF2-40B4-BE49-F238E27FC236}">
+                <a16:creationId xmlns:a16="http://schemas.microsoft.com/office/drawing/2014/main" id="{4DCFEE4C-96F0-C0B6-D22E-EFC7F6648D42}"/>
+              </a:ext>
+            </a:extLst>
+          </p:cNvPr>
+          <p:cNvSpPr txBox="1"/>
+          <p:nvPr/>
+        </p:nvSpPr>
+        <p:spPr>
+          <a:xfrm>
+            <a:off x="3988717" y="4979703"/>
+            <a:ext cx="2083594" cy="276999"/>
+          </a:xfrm>
+          <a:prstGeom prst="rect">
+            <a:avLst/>
+          </a:prstGeom>
+          <a:noFill/>
+        </p:spPr>
+        <p:txBody>
+          <a:bodyPr wrap="square">
+            <a:spAutoFit/>
+          </a:bodyPr>
+          <a:lstStyle/>
+          <a:p>
+            <a:r>
+              <a:rPr lang="en-US" altLang="zh-CN" sz="1200" b="1" dirty="0"/>
+              <a:t>Results &amp; Interpretation</a:t>
+            </a:r>
+            <a:endParaRPr lang="zh-CN" altLang="en-US" sz="1200" b="1" dirty="0"/>
+          </a:p>
+        </p:txBody>
+      </p:sp>
+      <p:sp>
+        <p:nvSpPr>
+          <p:cNvPr id="29" name="文本框 28">
+            <a:extLst>
+              <a:ext uri="{FF2B5EF4-FFF2-40B4-BE49-F238E27FC236}">
+                <a16:creationId xmlns:a16="http://schemas.microsoft.com/office/drawing/2014/main" id="{A1A8ED24-FC03-D42D-4DA4-5606BA3E41B4}"/>
+              </a:ext>
+            </a:extLst>
+          </p:cNvPr>
+          <p:cNvSpPr txBox="1"/>
+          <p:nvPr/>
+        </p:nvSpPr>
+        <p:spPr>
+          <a:xfrm>
+            <a:off x="3988717" y="5255277"/>
+            <a:ext cx="3783237" cy="1550874"/>
+          </a:xfrm>
+          <a:prstGeom prst="rect">
+            <a:avLst/>
+          </a:prstGeom>
+          <a:noFill/>
+        </p:spPr>
+        <p:txBody>
+          <a:bodyPr wrap="square">
+            <a:spAutoFit/>
+          </a:bodyPr>
+          <a:lstStyle/>
+          <a:p>
+            <a:pPr>
+              <a:lnSpc>
+                <a:spcPct val="150000"/>
+              </a:lnSpc>
+            </a:pPr>
+            <a:r>
+              <a:rPr lang="en-US" altLang="zh-CN" sz="800" b="1" dirty="0"/>
+              <a:t>1. MLP Results</a:t>
+            </a:r>
+            <a:endParaRPr lang="en-US" altLang="zh-CN" sz="800" dirty="0"/>
+          </a:p>
+          <a:p>
+            <a:pPr>
+              <a:lnSpc>
+                <a:spcPct val="150000"/>
+              </a:lnSpc>
+              <a:buFont typeface="Arial" panose="020B0604020202020204" pitchFamily="34" charset="0"/>
+              <a:buChar char="•"/>
+            </a:pPr>
+            <a:r>
+              <a:rPr lang="en-US" altLang="zh-CN" sz="800" b="1" dirty="0"/>
+              <a:t>Predictive Metrics:</a:t>
+            </a:r>
+            <a:r>
+              <a:rPr lang="en-US" altLang="zh-CN" sz="800" dirty="0"/>
+              <a:t> * Accuracy: </a:t>
+            </a:r>
+            <a:r>
+              <a:rPr lang="en-US" altLang="zh-CN" sz="800" b="1" dirty="0"/>
+              <a:t>93.97%</a:t>
+            </a:r>
+            <a:r>
+              <a:rPr lang="en-US" altLang="zh-CN" sz="800" dirty="0"/>
+              <a:t> </a:t>
+            </a:r>
+          </a:p>
+          <a:p>
+            <a:pPr marL="742950" lvl="1" indent="-285750">
+              <a:lnSpc>
+                <a:spcPct val="150000"/>
+              </a:lnSpc>
+              <a:buFont typeface="Arial" panose="020B0604020202020204" pitchFamily="34" charset="0"/>
+              <a:buChar char="•"/>
+            </a:pPr>
+            <a:r>
+              <a:rPr lang="en-US" altLang="zh-CN" sz="800" dirty="0"/>
+              <a:t>Precision: 0.9243 </a:t>
+            </a:r>
+          </a:p>
+          <a:p>
+            <a:pPr marL="742950" lvl="1" indent="-285750">
+              <a:lnSpc>
+                <a:spcPct val="150000"/>
+              </a:lnSpc>
+              <a:buFont typeface="Arial" panose="020B0604020202020204" pitchFamily="34" charset="0"/>
+              <a:buChar char="•"/>
+            </a:pPr>
+            <a:r>
+              <a:rPr lang="en-US" altLang="zh-CN" sz="800" dirty="0"/>
+              <a:t>Recall: </a:t>
+            </a:r>
+            <a:r>
+              <a:rPr lang="en-US" altLang="zh-CN" sz="800" b="1" dirty="0"/>
+              <a:t>0.9440</a:t>
+            </a:r>
+            <a:r>
+              <a:rPr lang="en-US" altLang="zh-CN" sz="800" dirty="0"/>
+              <a:t> </a:t>
+            </a:r>
+          </a:p>
+          <a:p>
+            <a:pPr marL="742950" lvl="1" indent="-285750">
+              <a:lnSpc>
+                <a:spcPct val="150000"/>
+              </a:lnSpc>
+              <a:buFont typeface="Arial" panose="020B0604020202020204" pitchFamily="34" charset="0"/>
+              <a:buChar char="•"/>
+            </a:pPr>
+            <a:r>
+              <a:rPr lang="en-US" altLang="zh-CN" sz="800" dirty="0"/>
+              <a:t>F1-Score: 0.9341 </a:t>
+            </a:r>
+          </a:p>
+          <a:p>
+            <a:pPr>
+              <a:lnSpc>
+                <a:spcPct val="150000"/>
+              </a:lnSpc>
+              <a:buFont typeface="Arial" panose="020B0604020202020204" pitchFamily="34" charset="0"/>
+              <a:buChar char="•"/>
+            </a:pPr>
+            <a:r>
+              <a:rPr lang="en-US" altLang="zh-CN" sz="800" b="1" dirty="0"/>
+              <a:t>Key Takeaway:</a:t>
+            </a:r>
+            <a:r>
+              <a:rPr lang="en-US" altLang="zh-CN" sz="800" dirty="0"/>
+              <a:t> The exceptionally high Recall indicates a very low rate of False Negatives. This ensures vulnerable structures are not mistakenly classified as safe, which is paramount for municipal planning.</a:t>
+            </a:r>
+          </a:p>
+        </p:txBody>
+      </p:sp>
+      <p:pic>
+        <p:nvPicPr>
+          <p:cNvPr id="30" name="图片 29" descr="图表, 瀑布图&#10;&#10;描述已自动生成">
+            <a:extLst>
+              <a:ext uri="{FF2B5EF4-FFF2-40B4-BE49-F238E27FC236}">
+                <a16:creationId xmlns:a16="http://schemas.microsoft.com/office/drawing/2014/main" id="{0FA33D50-9A06-1B8C-206F-9E672317CD59}"/>
+              </a:ext>
+            </a:extLst>
+          </p:cNvPr>
+          <p:cNvPicPr>
+            <a:picLocks noChangeAspect="1"/>
+          </p:cNvPicPr>
+          <p:nvPr/>
+        </p:nvPicPr>
+        <p:blipFill>
+          <a:blip r:embed="rId6">
+            <a:extLst>
+              <a:ext uri="{28A0092B-C50C-407E-A947-70E740481C1C}">
+                <a14:useLocalDpi xmlns:a14="http://schemas.microsoft.com/office/drawing/2010/main" val="0"/>
+              </a:ext>
+            </a:extLst>
+          </a:blip>
+          <a:stretch>
+            <a:fillRect/>
+          </a:stretch>
+        </p:blipFill>
+        <p:spPr>
+          <a:xfrm>
+            <a:off x="8104661" y="1673314"/>
+            <a:ext cx="3474062" cy="1365951"/>
+          </a:xfrm>
+          <a:prstGeom prst="rect">
+            <a:avLst/>
+          </a:prstGeom>
+        </p:spPr>
+      </p:pic>
+      <p:sp>
+        <p:nvSpPr>
+          <p:cNvPr id="32" name="文本框 31">
+            <a:extLst>
+              <a:ext uri="{FF2B5EF4-FFF2-40B4-BE49-F238E27FC236}">
+                <a16:creationId xmlns:a16="http://schemas.microsoft.com/office/drawing/2014/main" id="{A5E72279-EA8F-7D30-A34C-F03BC040B850}"/>
+              </a:ext>
+            </a:extLst>
+          </p:cNvPr>
+          <p:cNvSpPr txBox="1"/>
+          <p:nvPr/>
+        </p:nvSpPr>
+        <p:spPr>
+          <a:xfrm>
+            <a:off x="8107679" y="3041201"/>
+            <a:ext cx="6160168" cy="215444"/>
+          </a:xfrm>
+          <a:prstGeom prst="rect">
+            <a:avLst/>
+          </a:prstGeom>
+          <a:noFill/>
+        </p:spPr>
+        <p:txBody>
+          <a:bodyPr wrap="square">
+            <a:spAutoFit/>
+          </a:bodyPr>
+          <a:lstStyle/>
+          <a:p>
+            <a:r>
+              <a:rPr lang="en-US" altLang="zh-CN" sz="800" b="1" dirty="0"/>
+              <a:t>2. Bayesian Logistic Regression Results</a:t>
+            </a:r>
+            <a:endParaRPr lang="zh-CN" altLang="en-US" sz="800" b="1" dirty="0"/>
+          </a:p>
+        </p:txBody>
+      </p:sp>
+      <p:sp>
+        <p:nvSpPr>
+          <p:cNvPr id="34" name="文本框 33">
+            <a:extLst>
+              <a:ext uri="{FF2B5EF4-FFF2-40B4-BE49-F238E27FC236}">
+                <a16:creationId xmlns:a16="http://schemas.microsoft.com/office/drawing/2014/main" id="{59BCEA52-DE73-D2C1-ED32-D1E14D3F88E2}"/>
+              </a:ext>
+            </a:extLst>
+          </p:cNvPr>
+          <p:cNvSpPr txBox="1"/>
+          <p:nvPr/>
+        </p:nvSpPr>
+        <p:spPr>
+          <a:xfrm>
+            <a:off x="8104661" y="4515541"/>
+            <a:ext cx="4552606" cy="276999"/>
+          </a:xfrm>
+          <a:prstGeom prst="rect">
+            <a:avLst/>
+          </a:prstGeom>
+          <a:noFill/>
+        </p:spPr>
+        <p:txBody>
+          <a:bodyPr wrap="square">
+            <a:spAutoFit/>
+          </a:bodyPr>
+          <a:lstStyle/>
+          <a:p>
+            <a:r>
+              <a:rPr lang="en-US" altLang="zh-CN" sz="1200" b="1" dirty="0"/>
+              <a:t>Conclusions &amp; Future Work</a:t>
+            </a:r>
+            <a:endParaRPr lang="zh-CN" altLang="en-US" sz="1200" b="1" dirty="0"/>
+          </a:p>
+        </p:txBody>
+      </p:sp>
+      <p:sp>
+        <p:nvSpPr>
+          <p:cNvPr id="36" name="文本框 35">
+            <a:extLst>
+              <a:ext uri="{FF2B5EF4-FFF2-40B4-BE49-F238E27FC236}">
+                <a16:creationId xmlns:a16="http://schemas.microsoft.com/office/drawing/2014/main" id="{6919C17F-7A10-8D6F-3E05-E187A359625D}"/>
+              </a:ext>
+            </a:extLst>
+          </p:cNvPr>
+          <p:cNvSpPr txBox="1"/>
+          <p:nvPr/>
+        </p:nvSpPr>
+        <p:spPr>
+          <a:xfrm>
+            <a:off x="8104661" y="4792540"/>
+            <a:ext cx="3904248" cy="1735540"/>
+          </a:xfrm>
+          <a:prstGeom prst="rect">
+            <a:avLst/>
+          </a:prstGeom>
+          <a:noFill/>
+        </p:spPr>
+        <p:txBody>
+          <a:bodyPr wrap="square">
+            <a:spAutoFit/>
+          </a:bodyPr>
+          <a:lstStyle/>
+          <a:p>
+            <a:pPr>
+              <a:lnSpc>
+                <a:spcPct val="150000"/>
+              </a:lnSpc>
+            </a:pPr>
+            <a:r>
+              <a:rPr lang="en-US" altLang="zh-CN" sz="800" b="1" dirty="0">
+                <a:effectLst/>
+              </a:rPr>
+              <a:t>Model Trade-offs:</a:t>
+            </a:r>
+            <a:r>
+              <a:rPr lang="en-US" altLang="zh-CN" sz="800" dirty="0">
+                <a:effectLst/>
+              </a:rPr>
+              <a:t> The MLP demonstrated superior capability in capturing complex, non-linear structural patterns (high accuracy). However, it suffers from a "black-box" nature compared to the probabilistic, easily interpretable coefficients provided by the Bayesian approach.</a:t>
+            </a:r>
+          </a:p>
+          <a:p>
+            <a:pPr>
+              <a:lnSpc>
+                <a:spcPct val="150000"/>
+              </a:lnSpc>
+            </a:pPr>
+            <a:r>
+              <a:rPr lang="en-US" altLang="zh-CN" sz="800" b="1" dirty="0">
+                <a:effectLst/>
+              </a:rPr>
+              <a:t>Future Directions:</a:t>
+            </a:r>
+            <a:r>
+              <a:rPr lang="en-US" altLang="zh-CN" sz="800" dirty="0">
+                <a:effectLst/>
+              </a:rPr>
+              <a:t> * Expand the dataset to include diverse geographical regions.</a:t>
+            </a:r>
+          </a:p>
+          <a:p>
+            <a:pPr>
+              <a:lnSpc>
+                <a:spcPct val="150000"/>
+              </a:lnSpc>
+              <a:buFont typeface="Arial" panose="020B0604020202020204" pitchFamily="34" charset="0"/>
+              <a:buChar char="•"/>
+            </a:pPr>
+            <a:r>
+              <a:rPr lang="en-US" altLang="zh-CN" sz="800" dirty="0">
+                <a:effectLst/>
+              </a:rPr>
+              <a:t>Incorporate a post-hoc interpretability framework, such as </a:t>
+            </a:r>
+            <a:r>
+              <a:rPr lang="en-US" altLang="zh-CN" sz="800" b="1" dirty="0">
+                <a:effectLst/>
+              </a:rPr>
+              <a:t>SHAP values</a:t>
+            </a:r>
+            <a:r>
+              <a:rPr lang="en-US" altLang="zh-CN" sz="800" dirty="0">
+                <a:effectLst/>
+              </a:rPr>
+              <a:t>, to understand the marginal contribution of individual building attributes (e.g., ground elevation) to the MLP's predictions.</a:t>
+            </a:r>
+          </a:p>
+          <a:p>
+            <a:pPr>
+              <a:lnSpc>
+                <a:spcPct val="150000"/>
+              </a:lnSpc>
+            </a:pPr>
+            <a:r>
+              <a:rPr lang="en-US" altLang="zh-CN" sz="800" b="1" dirty="0" err="1"/>
+              <a:t>Xxxxxxxxxxxxxxx</a:t>
+            </a:r>
+            <a:r>
+              <a:rPr lang="en-US" altLang="zh-CN" sz="800" b="1" dirty="0"/>
+              <a:t>: </a:t>
+            </a:r>
+            <a:endParaRPr lang="en-US" altLang="zh-CN" sz="800" b="1" dirty="0">
+              <a:effectLst/>
+            </a:endParaRPr>
+          </a:p>
+        </p:txBody>
+      </p:sp>
+      <p:sp>
+        <p:nvSpPr>
+          <p:cNvPr id="38" name="文本框 37">
+            <a:extLst>
+              <a:ext uri="{FF2B5EF4-FFF2-40B4-BE49-F238E27FC236}">
+                <a16:creationId xmlns:a16="http://schemas.microsoft.com/office/drawing/2014/main" id="{BC9559D7-5281-2428-7711-D533D437D889}"/>
+              </a:ext>
+            </a:extLst>
+          </p:cNvPr>
+          <p:cNvSpPr txBox="1"/>
+          <p:nvPr/>
+        </p:nvSpPr>
+        <p:spPr>
+          <a:xfrm>
+            <a:off x="8107679" y="1429322"/>
+            <a:ext cx="7196202" cy="258212"/>
+          </a:xfrm>
+          <a:prstGeom prst="rect">
+            <a:avLst/>
+          </a:prstGeom>
+          <a:noFill/>
+        </p:spPr>
+        <p:txBody>
+          <a:bodyPr wrap="square">
+            <a:spAutoFit/>
+          </a:bodyPr>
+          <a:lstStyle/>
+          <a:p>
+            <a:pPr>
+              <a:lnSpc>
+                <a:spcPct val="150000"/>
+              </a:lnSpc>
+            </a:pPr>
+            <a:r>
+              <a:rPr lang="en-US" altLang="zh-CN" sz="800" b="1" dirty="0"/>
+              <a:t>Figures of MLP Results</a:t>
+            </a:r>
+            <a:endParaRPr lang="en-US" altLang="zh-CN" sz="800" dirty="0"/>
+          </a:p>
+        </p:txBody>
+      </p:sp>
+      <p:sp>
+        <p:nvSpPr>
+          <p:cNvPr id="41" name="文本框 40">
+            <a:extLst>
+              <a:ext uri="{FF2B5EF4-FFF2-40B4-BE49-F238E27FC236}">
+                <a16:creationId xmlns:a16="http://schemas.microsoft.com/office/drawing/2014/main" id="{BD18A631-6558-539C-2A8A-22CA6F4955CD}"/>
+              </a:ext>
+            </a:extLst>
+          </p:cNvPr>
+          <p:cNvSpPr txBox="1"/>
+          <p:nvPr/>
+        </p:nvSpPr>
+        <p:spPr>
+          <a:xfrm>
+            <a:off x="301083" y="5319717"/>
+            <a:ext cx="1243237" cy="276999"/>
+          </a:xfrm>
+          <a:prstGeom prst="rect">
+            <a:avLst/>
+          </a:prstGeom>
+          <a:noFill/>
+        </p:spPr>
+        <p:txBody>
+          <a:bodyPr wrap="square">
+            <a:spAutoFit/>
+          </a:bodyPr>
+          <a:lstStyle/>
+          <a:p>
+            <a:r>
+              <a:rPr lang="en-US" altLang="zh-CN" sz="1200" b="1" dirty="0"/>
+              <a:t>References</a:t>
+            </a:r>
+            <a:endParaRPr lang="zh-CN" altLang="en-US" sz="1200" b="1" dirty="0"/>
+          </a:p>
+        </p:txBody>
+      </p:sp>
+      <p:sp>
+        <p:nvSpPr>
+          <p:cNvPr id="43" name="文本框 42">
+            <a:extLst>
+              <a:ext uri="{FF2B5EF4-FFF2-40B4-BE49-F238E27FC236}">
+                <a16:creationId xmlns:a16="http://schemas.microsoft.com/office/drawing/2014/main" id="{59075793-09F4-4097-6EA4-2856CA1F9C9D}"/>
+              </a:ext>
+            </a:extLst>
+          </p:cNvPr>
+          <p:cNvSpPr txBox="1"/>
+          <p:nvPr/>
+        </p:nvSpPr>
+        <p:spPr>
+          <a:xfrm>
+            <a:off x="293525" y="5553139"/>
+            <a:ext cx="2387708" cy="1186222"/>
+          </a:xfrm>
+          <a:prstGeom prst="rect">
+            <a:avLst/>
+          </a:prstGeom>
+          <a:noFill/>
+        </p:spPr>
+        <p:txBody>
+          <a:bodyPr wrap="square">
+            <a:spAutoFit/>
+          </a:bodyPr>
+          <a:lstStyle/>
+          <a:p>
+            <a:pPr>
+              <a:lnSpc>
+                <a:spcPct val="150000"/>
+              </a:lnSpc>
+            </a:pPr>
+            <a:r>
+              <a:rPr lang="en-US" altLang="zh-CN" sz="600" dirty="0" err="1"/>
+              <a:t>Demissie</a:t>
+            </a:r>
+            <a:r>
+              <a:rPr lang="en-US" altLang="zh-CN" sz="600" dirty="0"/>
+              <a:t>, Z., et al. (2024). </a:t>
+            </a:r>
+            <a:r>
+              <a:rPr lang="en-US" altLang="zh-CN" sz="600" i="1" dirty="0"/>
+              <a:t>Applied Computing and Geosciences, 23</a:t>
+            </a:r>
+            <a:r>
+              <a:rPr lang="en-US" altLang="zh-CN" sz="600" dirty="0"/>
+              <a:t>, 100183.</a:t>
+            </a:r>
+          </a:p>
+          <a:p>
+            <a:pPr>
+              <a:lnSpc>
+                <a:spcPct val="150000"/>
+              </a:lnSpc>
+            </a:pPr>
+            <a:r>
+              <a:rPr lang="en-US" altLang="zh-CN" sz="600" dirty="0"/>
+              <a:t>Chen, Y., et al. (2023). </a:t>
+            </a:r>
+            <a:r>
+              <a:rPr lang="en-US" altLang="zh-CN" sz="600" i="1" dirty="0"/>
+              <a:t>Frontiers in Earth Science, 11</a:t>
+            </a:r>
+            <a:r>
+              <a:rPr lang="en-US" altLang="zh-CN" sz="600" dirty="0"/>
+              <a:t>, 1117004.</a:t>
+            </a:r>
+          </a:p>
+          <a:p>
+            <a:pPr>
+              <a:lnSpc>
+                <a:spcPct val="150000"/>
+              </a:lnSpc>
+            </a:pPr>
+            <a:r>
+              <a:rPr lang="en-US" altLang="zh-CN" sz="600" dirty="0" err="1"/>
+              <a:t>Ouma</a:t>
+            </a:r>
+            <a:r>
+              <a:rPr lang="en-US" altLang="zh-CN" sz="600" dirty="0"/>
+              <a:t>, Y. O., &amp; Lawrence, O. (2023). </a:t>
+            </a:r>
+            <a:r>
+              <a:rPr lang="en-US" altLang="zh-CN" sz="600" i="1" dirty="0"/>
+              <a:t>Int. J. of Intelligent Systems 2023</a:t>
+            </a:r>
+            <a:r>
+              <a:rPr lang="en-US" altLang="zh-CN" sz="600" dirty="0"/>
+              <a:t>, 5672401.</a:t>
+            </a:r>
+          </a:p>
+          <a:p>
+            <a:pPr>
+              <a:lnSpc>
+                <a:spcPct val="150000"/>
+              </a:lnSpc>
+            </a:pPr>
+            <a:r>
+              <a:rPr lang="en-US" altLang="zh-CN" sz="600" dirty="0"/>
+              <a:t>Qin, X., et al. (2025). </a:t>
+            </a:r>
+            <a:r>
+              <a:rPr lang="en-US" altLang="zh-CN" sz="600" i="1" dirty="0" err="1"/>
+              <a:t>npj</a:t>
+            </a:r>
+            <a:r>
+              <a:rPr lang="en-US" altLang="zh-CN" sz="600" i="1" dirty="0"/>
+              <a:t> Urban Sustainability, 5</a:t>
+            </a:r>
+            <a:r>
+              <a:rPr lang="en-US" altLang="zh-CN" sz="600" dirty="0"/>
+              <a:t>, 19.</a:t>
+            </a:r>
+          </a:p>
+          <a:p>
+            <a:pPr>
+              <a:lnSpc>
+                <a:spcPct val="150000"/>
+              </a:lnSpc>
+            </a:pPr>
+            <a:r>
+              <a:rPr lang="en-US" altLang="zh-CN" sz="600" dirty="0"/>
+              <a:t>U.S. Army Corps of Engineers. </a:t>
+            </a:r>
+            <a:r>
+              <a:rPr lang="en-US" altLang="zh-CN" sz="600" i="1" dirty="0"/>
+              <a:t>National Structure Inventory (NSI) Technical Documentation.</a:t>
+            </a:r>
+            <a:endParaRPr lang="en-US" altLang="zh-CN" sz="600" dirty="0"/>
+          </a:p>
+        </p:txBody>
+      </p:sp>
+      <p:sp>
+        <p:nvSpPr>
+          <p:cNvPr id="44" name="文本框 43">
+            <a:extLst>
+              <a:ext uri="{FF2B5EF4-FFF2-40B4-BE49-F238E27FC236}">
+                <a16:creationId xmlns:a16="http://schemas.microsoft.com/office/drawing/2014/main" id="{1E260EDA-B575-8EF5-5E2A-26ED48648462}"/>
+              </a:ext>
+            </a:extLst>
+          </p:cNvPr>
+          <p:cNvSpPr txBox="1"/>
+          <p:nvPr/>
+        </p:nvSpPr>
+        <p:spPr>
+          <a:xfrm>
+            <a:off x="1423143" y="671847"/>
+            <a:ext cx="1400895" cy="553998"/>
+          </a:xfrm>
+          <a:prstGeom prst="rect">
+            <a:avLst/>
+          </a:prstGeom>
+          <a:noFill/>
+        </p:spPr>
+        <p:txBody>
+          <a:bodyPr wrap="square">
+            <a:spAutoFit/>
+          </a:bodyPr>
+          <a:lstStyle/>
+          <a:p>
+            <a:r>
+              <a:rPr lang="en-US" altLang="zh-CN" sz="3000" dirty="0"/>
+              <a:t>🌊</a:t>
+            </a:r>
+            <a:r>
+              <a:rPr lang="zh-CN" altLang="en-US" sz="3000" dirty="0"/>
+              <a:t> </a:t>
+            </a:r>
+            <a:r>
+              <a:rPr lang="en-US" altLang="zh-CN" sz="3000" dirty="0"/>
+              <a:t>☠️</a:t>
+            </a:r>
+          </a:p>
+        </p:txBody>
+      </p:sp>
+      <p:sp>
+        <p:nvSpPr>
+          <p:cNvPr id="45" name="文本框 44">
+            <a:extLst>
+              <a:ext uri="{FF2B5EF4-FFF2-40B4-BE49-F238E27FC236}">
+                <a16:creationId xmlns:a16="http://schemas.microsoft.com/office/drawing/2014/main" id="{ED5F1581-D4F4-FEE8-6E9D-762A29AD1C92}"/>
+              </a:ext>
+            </a:extLst>
+          </p:cNvPr>
+          <p:cNvSpPr txBox="1"/>
+          <p:nvPr/>
+        </p:nvSpPr>
+        <p:spPr>
+          <a:xfrm>
+            <a:off x="2890829" y="681486"/>
+            <a:ext cx="1400895" cy="553998"/>
+          </a:xfrm>
+          <a:prstGeom prst="rect">
+            <a:avLst/>
+          </a:prstGeom>
+          <a:noFill/>
+        </p:spPr>
+        <p:txBody>
+          <a:bodyPr wrap="square">
+            <a:spAutoFit/>
+          </a:bodyPr>
+          <a:lstStyle/>
+          <a:p>
+            <a:r>
+              <a:rPr lang="en-US" altLang="zh-CN" sz="3000" dirty="0"/>
+              <a:t>🌊</a:t>
+            </a:r>
+            <a:r>
+              <a:rPr lang="zh-CN" altLang="en-US" sz="3000" dirty="0"/>
+              <a:t> </a:t>
+            </a:r>
+            <a:r>
+              <a:rPr lang="en-US" altLang="zh-CN" sz="3000" dirty="0"/>
+              <a:t>☠️</a:t>
+            </a:r>
+          </a:p>
+        </p:txBody>
+      </p:sp>
+      <p:sp>
+        <p:nvSpPr>
+          <p:cNvPr id="46" name="文本框 45">
+            <a:extLst>
+              <a:ext uri="{FF2B5EF4-FFF2-40B4-BE49-F238E27FC236}">
+                <a16:creationId xmlns:a16="http://schemas.microsoft.com/office/drawing/2014/main" id="{565AD4E5-77B8-1316-BAAA-AF64EA79CA17}"/>
+              </a:ext>
+            </a:extLst>
+          </p:cNvPr>
+          <p:cNvSpPr txBox="1"/>
+          <p:nvPr/>
+        </p:nvSpPr>
+        <p:spPr>
+          <a:xfrm>
+            <a:off x="7771954" y="668350"/>
+            <a:ext cx="1400895" cy="553998"/>
+          </a:xfrm>
+          <a:prstGeom prst="rect">
+            <a:avLst/>
+          </a:prstGeom>
+          <a:noFill/>
+        </p:spPr>
+        <p:txBody>
+          <a:bodyPr wrap="square">
+            <a:spAutoFit/>
+          </a:bodyPr>
+          <a:lstStyle/>
+          <a:p>
+            <a:r>
+              <a:rPr lang="en-US" altLang="zh-CN" sz="3000" dirty="0"/>
+              <a:t>🌊</a:t>
+            </a:r>
+            <a:r>
+              <a:rPr lang="zh-CN" altLang="en-US" sz="3000" dirty="0"/>
+              <a:t> </a:t>
+            </a:r>
+            <a:r>
+              <a:rPr lang="en-US" altLang="zh-CN" sz="3000" dirty="0"/>
+              <a:t>☠️</a:t>
+            </a:r>
+          </a:p>
+        </p:txBody>
+      </p:sp>
+      <p:sp>
+        <p:nvSpPr>
+          <p:cNvPr id="47" name="文本框 46">
+            <a:extLst>
+              <a:ext uri="{FF2B5EF4-FFF2-40B4-BE49-F238E27FC236}">
+                <a16:creationId xmlns:a16="http://schemas.microsoft.com/office/drawing/2014/main" id="{324828A1-1A13-E73E-E7B8-5E5493327EB5}"/>
+              </a:ext>
+            </a:extLst>
+          </p:cNvPr>
+          <p:cNvSpPr txBox="1"/>
+          <p:nvPr/>
+        </p:nvSpPr>
+        <p:spPr>
+          <a:xfrm>
+            <a:off x="9135727" y="668350"/>
+            <a:ext cx="1400895" cy="553998"/>
+          </a:xfrm>
+          <a:prstGeom prst="rect">
+            <a:avLst/>
+          </a:prstGeom>
+          <a:noFill/>
+        </p:spPr>
+        <p:txBody>
+          <a:bodyPr wrap="square">
+            <a:spAutoFit/>
+          </a:bodyPr>
+          <a:lstStyle/>
+          <a:p>
+            <a:r>
+              <a:rPr lang="en-US" altLang="zh-CN" sz="3000" dirty="0"/>
+              <a:t>🌊</a:t>
+            </a:r>
+            <a:r>
+              <a:rPr lang="zh-CN" altLang="en-US" sz="3000" dirty="0"/>
+              <a:t> </a:t>
+            </a:r>
+            <a:r>
+              <a:rPr lang="en-US" altLang="zh-CN" sz="3000" dirty="0"/>
+              <a:t>☠️</a:t>
+            </a:r>
+          </a:p>
+        </p:txBody>
+      </p:sp>
+      <p:sp>
+        <p:nvSpPr>
+          <p:cNvPr id="48" name="文本框 47">
+            <a:extLst>
+              <a:ext uri="{FF2B5EF4-FFF2-40B4-BE49-F238E27FC236}">
+                <a16:creationId xmlns:a16="http://schemas.microsoft.com/office/drawing/2014/main" id="{3243B57C-B631-1FB2-A9D9-33E26EC8F9FF}"/>
+              </a:ext>
+            </a:extLst>
+          </p:cNvPr>
+          <p:cNvSpPr txBox="1"/>
+          <p:nvPr/>
+        </p:nvSpPr>
+        <p:spPr>
+          <a:xfrm>
+            <a:off x="10553820" y="668350"/>
+            <a:ext cx="1400895" cy="553998"/>
+          </a:xfrm>
+          <a:prstGeom prst="rect">
+            <a:avLst/>
+          </a:prstGeom>
+          <a:noFill/>
+        </p:spPr>
+        <p:txBody>
+          <a:bodyPr wrap="square">
+            <a:spAutoFit/>
+          </a:bodyPr>
+          <a:lstStyle/>
+          <a:p>
+            <a:r>
+              <a:rPr lang="en-US" altLang="zh-CN" sz="3000" dirty="0"/>
+              <a:t>🌊</a:t>
+            </a:r>
+            <a:r>
+              <a:rPr lang="zh-CN" altLang="en-US" sz="3000" dirty="0"/>
+              <a:t> </a:t>
+            </a:r>
+            <a:r>
+              <a:rPr lang="en-US" altLang="zh-CN" sz="3000" dirty="0"/>
+              <a:t>☠️</a:t>
+            </a:r>
+          </a:p>
+        </p:txBody>
+      </p:sp>
     </p:spTree>
     <p:extLst>
       <p:ext uri="{BB962C8B-B14F-4D97-AF65-F5344CB8AC3E}">

</xml_diff>

<commit_message>
Final editions and pdfs
</commit_message>
<xml_diff>
--- a/4420 poster.pptx
+++ b/4420 poster.pptx
@@ -432,7 +432,7 @@
           <a:p>
             <a:fld id="{4F3CE88B-B02B-184C-9CAE-9FCDA7167E7A}" type="datetimeFigureOut">
               <a:rPr kumimoji="1" lang="zh-CN" altLang="en-US" smtClean="0"/>
-              <a:t>2026/4/14</a:t>
+              <a:t>2026/4/15</a:t>
             </a:fld>
             <a:endParaRPr kumimoji="1" lang="zh-CN" altLang="en-US"/>
           </a:p>
@@ -630,7 +630,7 @@
           <a:p>
             <a:fld id="{4F3CE88B-B02B-184C-9CAE-9FCDA7167E7A}" type="datetimeFigureOut">
               <a:rPr kumimoji="1" lang="zh-CN" altLang="en-US" smtClean="0"/>
-              <a:t>2026/4/14</a:t>
+              <a:t>2026/4/15</a:t>
             </a:fld>
             <a:endParaRPr kumimoji="1" lang="zh-CN" altLang="en-US"/>
           </a:p>
@@ -838,7 +838,7 @@
           <a:p>
             <a:fld id="{4F3CE88B-B02B-184C-9CAE-9FCDA7167E7A}" type="datetimeFigureOut">
               <a:rPr kumimoji="1" lang="zh-CN" altLang="en-US" smtClean="0"/>
-              <a:t>2026/4/14</a:t>
+              <a:t>2026/4/15</a:t>
             </a:fld>
             <a:endParaRPr kumimoji="1" lang="zh-CN" altLang="en-US"/>
           </a:p>
@@ -1036,7 +1036,7 @@
           <a:p>
             <a:fld id="{4F3CE88B-B02B-184C-9CAE-9FCDA7167E7A}" type="datetimeFigureOut">
               <a:rPr kumimoji="1" lang="zh-CN" altLang="en-US" smtClean="0"/>
-              <a:t>2026/4/14</a:t>
+              <a:t>2026/4/15</a:t>
             </a:fld>
             <a:endParaRPr kumimoji="1" lang="zh-CN" altLang="en-US"/>
           </a:p>
@@ -1311,7 +1311,7 @@
           <a:p>
             <a:fld id="{4F3CE88B-B02B-184C-9CAE-9FCDA7167E7A}" type="datetimeFigureOut">
               <a:rPr kumimoji="1" lang="zh-CN" altLang="en-US" smtClean="0"/>
-              <a:t>2026/4/14</a:t>
+              <a:t>2026/4/15</a:t>
             </a:fld>
             <a:endParaRPr kumimoji="1" lang="zh-CN" altLang="en-US"/>
           </a:p>
@@ -1576,7 +1576,7 @@
           <a:p>
             <a:fld id="{4F3CE88B-B02B-184C-9CAE-9FCDA7167E7A}" type="datetimeFigureOut">
               <a:rPr kumimoji="1" lang="zh-CN" altLang="en-US" smtClean="0"/>
-              <a:t>2026/4/14</a:t>
+              <a:t>2026/4/15</a:t>
             </a:fld>
             <a:endParaRPr kumimoji="1" lang="zh-CN" altLang="en-US"/>
           </a:p>
@@ -1988,7 +1988,7 @@
           <a:p>
             <a:fld id="{4F3CE88B-B02B-184C-9CAE-9FCDA7167E7A}" type="datetimeFigureOut">
               <a:rPr kumimoji="1" lang="zh-CN" altLang="en-US" smtClean="0"/>
-              <a:t>2026/4/14</a:t>
+              <a:t>2026/4/15</a:t>
             </a:fld>
             <a:endParaRPr kumimoji="1" lang="zh-CN" altLang="en-US"/>
           </a:p>
@@ -2129,7 +2129,7 @@
           <a:p>
             <a:fld id="{4F3CE88B-B02B-184C-9CAE-9FCDA7167E7A}" type="datetimeFigureOut">
               <a:rPr kumimoji="1" lang="zh-CN" altLang="en-US" smtClean="0"/>
-              <a:t>2026/4/14</a:t>
+              <a:t>2026/4/15</a:t>
             </a:fld>
             <a:endParaRPr kumimoji="1" lang="zh-CN" altLang="en-US"/>
           </a:p>
@@ -2242,7 +2242,7 @@
           <a:p>
             <a:fld id="{4F3CE88B-B02B-184C-9CAE-9FCDA7167E7A}" type="datetimeFigureOut">
               <a:rPr kumimoji="1" lang="zh-CN" altLang="en-US" smtClean="0"/>
-              <a:t>2026/4/14</a:t>
+              <a:t>2026/4/15</a:t>
             </a:fld>
             <a:endParaRPr kumimoji="1" lang="zh-CN" altLang="en-US"/>
           </a:p>
@@ -2553,7 +2553,7 @@
           <a:p>
             <a:fld id="{4F3CE88B-B02B-184C-9CAE-9FCDA7167E7A}" type="datetimeFigureOut">
               <a:rPr kumimoji="1" lang="zh-CN" altLang="en-US" smtClean="0"/>
-              <a:t>2026/4/14</a:t>
+              <a:t>2026/4/15</a:t>
             </a:fld>
             <a:endParaRPr kumimoji="1" lang="zh-CN" altLang="en-US"/>
           </a:p>
@@ -2841,7 +2841,7 @@
           <a:p>
             <a:fld id="{4F3CE88B-B02B-184C-9CAE-9FCDA7167E7A}" type="datetimeFigureOut">
               <a:rPr kumimoji="1" lang="zh-CN" altLang="en-US" smtClean="0"/>
-              <a:t>2026/4/14</a:t>
+              <a:t>2026/4/15</a:t>
             </a:fld>
             <a:endParaRPr kumimoji="1" lang="zh-CN" altLang="en-US"/>
           </a:p>
@@ -3082,7 +3082,7 @@
           <a:p>
             <a:fld id="{4F3CE88B-B02B-184C-9CAE-9FCDA7167E7A}" type="datetimeFigureOut">
               <a:rPr kumimoji="1" lang="zh-CN" altLang="en-US" smtClean="0"/>
-              <a:t>2026/4/14</a:t>
+              <a:t>2026/4/15</a:t>
             </a:fld>
             <a:endParaRPr kumimoji="1" lang="zh-CN" altLang="en-US"/>
           </a:p>
@@ -3844,7 +3844,7 @@
         <p:spPr>
           <a:xfrm>
             <a:off x="293525" y="3607390"/>
-            <a:ext cx="2259237" cy="1735540"/>
+            <a:ext cx="3270697" cy="1550874"/>
           </a:xfrm>
           <a:prstGeom prst="rect">
             <a:avLst/>
@@ -4041,7 +4041,7 @@
         </p:nvSpPr>
         <p:spPr>
           <a:xfrm>
-            <a:off x="4003411" y="1235484"/>
+            <a:off x="3825774" y="1248979"/>
             <a:ext cx="1788160" cy="276999"/>
           </a:xfrm>
           <a:prstGeom prst="rect">
@@ -4077,7 +4077,7 @@
         </p:nvSpPr>
         <p:spPr>
           <a:xfrm>
-            <a:off x="4003411" y="1523547"/>
+            <a:off x="3825774" y="1545394"/>
             <a:ext cx="4104269" cy="1365951"/>
           </a:xfrm>
           <a:prstGeom prst="rect">
@@ -4255,7 +4255,7 @@
         </p:blipFill>
         <p:spPr>
           <a:xfrm>
-            <a:off x="6722269" y="1945997"/>
+            <a:off x="6639830" y="1968915"/>
             <a:ext cx="940797" cy="364857"/>
           </a:xfrm>
           <a:prstGeom prst="rect">
@@ -4285,7 +4285,7 @@
         </p:blipFill>
         <p:spPr>
           <a:xfrm>
-            <a:off x="5233711" y="2650040"/>
+            <a:off x="5081619" y="2664087"/>
             <a:ext cx="1640650" cy="339784"/>
           </a:xfrm>
           <a:prstGeom prst="rect">
@@ -4307,7 +4307,7 @@
         </p:nvSpPr>
         <p:spPr>
           <a:xfrm>
-            <a:off x="4003411" y="2928991"/>
+            <a:off x="3825774" y="2940526"/>
             <a:ext cx="6157912" cy="215444"/>
           </a:xfrm>
           <a:prstGeom prst="rect">
@@ -4351,7 +4351,7 @@
         </p:nvSpPr>
         <p:spPr>
           <a:xfrm>
-            <a:off x="3941314" y="4459164"/>
+            <a:off x="3738324" y="4466141"/>
             <a:ext cx="2083594" cy="276999"/>
           </a:xfrm>
           <a:prstGeom prst="rect">
@@ -4387,7 +4387,7 @@
         </p:nvSpPr>
         <p:spPr>
           <a:xfrm>
-            <a:off x="3941314" y="4734738"/>
+            <a:off x="3797390" y="4675678"/>
             <a:ext cx="3783237" cy="1920206"/>
           </a:xfrm>
           <a:prstGeom prst="rect">
@@ -4561,7 +4561,7 @@
         </p:nvSpPr>
         <p:spPr>
           <a:xfrm>
-            <a:off x="6024908" y="4804321"/>
+            <a:off x="5801442" y="4737531"/>
             <a:ext cx="2012353" cy="1077218"/>
           </a:xfrm>
           <a:prstGeom prst="rect">
@@ -4833,7 +4833,7 @@
         </p:nvSpPr>
         <p:spPr>
           <a:xfrm>
-            <a:off x="301083" y="5319717"/>
+            <a:off x="293525" y="5217202"/>
             <a:ext cx="1243237" cy="276999"/>
           </a:xfrm>
           <a:prstGeom prst="rect">
@@ -4869,8 +4869,8 @@
         </p:nvSpPr>
         <p:spPr>
           <a:xfrm>
-            <a:off x="293525" y="5553139"/>
-            <a:ext cx="2387708" cy="1186222"/>
+            <a:off x="301083" y="5494201"/>
+            <a:ext cx="2798956" cy="1368580"/>
           </a:xfrm>
           <a:prstGeom prst="rect">
             <a:avLst/>
@@ -4889,19 +4889,19 @@
               </a:lnSpc>
             </a:pPr>
             <a:r>
-              <a:rPr lang="en-US" altLang="zh-CN" sz="600" dirty="0" err="1"/>
+              <a:rPr lang="en-US" altLang="zh-CN" sz="700" dirty="0" err="1"/>
               <a:t>Demissie</a:t>
             </a:r>
             <a:r>
-              <a:rPr lang="en-US" altLang="zh-CN" sz="600" dirty="0"/>
+              <a:rPr lang="en-US" altLang="zh-CN" sz="700" dirty="0"/>
               <a:t>, Z., et al. (2024). </a:t>
             </a:r>
             <a:r>
-              <a:rPr lang="en-US" altLang="zh-CN" sz="600" i="1" dirty="0"/>
+              <a:rPr lang="en-US" altLang="zh-CN" sz="700" i="1" dirty="0"/>
               <a:t>Applied Computing and Geosciences, 23</a:t>
             </a:r>
             <a:r>
-              <a:rPr lang="en-US" altLang="zh-CN" sz="600" dirty="0"/>
+              <a:rPr lang="en-US" altLang="zh-CN" sz="700" dirty="0"/>
               <a:t>, 100183.</a:t>
             </a:r>
           </a:p>
@@ -4912,15 +4912,15 @@
               </a:lnSpc>
             </a:pPr>
             <a:r>
-              <a:rPr lang="en-US" altLang="zh-CN" sz="600" dirty="0"/>
+              <a:rPr lang="en-US" altLang="zh-CN" sz="700" dirty="0"/>
               <a:t>Chen, Y., et al. (2023). </a:t>
             </a:r>
             <a:r>
-              <a:rPr lang="en-US" altLang="zh-CN" sz="600" i="1" dirty="0"/>
+              <a:rPr lang="en-US" altLang="zh-CN" sz="700" i="1" dirty="0"/>
               <a:t>Frontiers in Earth Science, 11</a:t>
             </a:r>
             <a:r>
-              <a:rPr lang="en-US" altLang="zh-CN" sz="600" dirty="0"/>
+              <a:rPr lang="en-US" altLang="zh-CN" sz="700" dirty="0"/>
               <a:t>, 1117004.</a:t>
             </a:r>
           </a:p>
@@ -4931,19 +4931,19 @@
               </a:lnSpc>
             </a:pPr>
             <a:r>
-              <a:rPr lang="en-US" altLang="zh-CN" sz="600" dirty="0" err="1"/>
+              <a:rPr lang="en-US" altLang="zh-CN" sz="700" dirty="0" err="1"/>
               <a:t>Ouma</a:t>
             </a:r>
             <a:r>
-              <a:rPr lang="en-US" altLang="zh-CN" sz="600" dirty="0"/>
+              <a:rPr lang="en-US" altLang="zh-CN" sz="700" dirty="0"/>
               <a:t>, Y. O., &amp; Lawrence, O. (2023). </a:t>
             </a:r>
             <a:r>
-              <a:rPr lang="en-US" altLang="zh-CN" sz="600" i="1" dirty="0"/>
+              <a:rPr lang="en-US" altLang="zh-CN" sz="700" i="1" dirty="0"/>
               <a:t>Int. J. of Intelligent Systems 2023</a:t>
             </a:r>
             <a:r>
-              <a:rPr lang="en-US" altLang="zh-CN" sz="600" dirty="0"/>
+              <a:rPr lang="en-US" altLang="zh-CN" sz="700" dirty="0"/>
               <a:t>, 5672401.</a:t>
             </a:r>
           </a:p>
@@ -4954,19 +4954,19 @@
               </a:lnSpc>
             </a:pPr>
             <a:r>
-              <a:rPr lang="en-US" altLang="zh-CN" sz="600" dirty="0"/>
+              <a:rPr lang="en-US" altLang="zh-CN" sz="700" dirty="0"/>
               <a:t>Qin, X., et al. (2025). </a:t>
             </a:r>
             <a:r>
-              <a:rPr lang="en-US" altLang="zh-CN" sz="600" i="1" dirty="0" err="1"/>
+              <a:rPr lang="en-US" altLang="zh-CN" sz="700" i="1" dirty="0" err="1"/>
               <a:t>npj</a:t>
             </a:r>
             <a:r>
-              <a:rPr lang="en-US" altLang="zh-CN" sz="600" i="1" dirty="0"/>
+              <a:rPr lang="en-US" altLang="zh-CN" sz="700" i="1" dirty="0"/>
               <a:t> Urban Sustainability, 5</a:t>
             </a:r>
             <a:r>
-              <a:rPr lang="en-US" altLang="zh-CN" sz="600" dirty="0"/>
+              <a:rPr lang="en-US" altLang="zh-CN" sz="700" dirty="0"/>
               <a:t>, 19.</a:t>
             </a:r>
           </a:p>
@@ -4977,14 +4977,14 @@
               </a:lnSpc>
             </a:pPr>
             <a:r>
-              <a:rPr lang="en-US" altLang="zh-CN" sz="600" dirty="0"/>
+              <a:rPr lang="en-US" altLang="zh-CN" sz="700" dirty="0"/>
               <a:t>U.S. Army Corps of Engineers. </a:t>
             </a:r>
             <a:r>
-              <a:rPr lang="en-US" altLang="zh-CN" sz="600" i="1" dirty="0"/>
+              <a:rPr lang="en-US" altLang="zh-CN" sz="700" i="1" dirty="0"/>
               <a:t>National Structure Inventory (NSI) Technical Documentation.</a:t>
             </a:r>
-            <a:endParaRPr lang="en-US" altLang="zh-CN" sz="600" dirty="0"/>
+            <a:endParaRPr lang="en-US" altLang="zh-CN" sz="700" dirty="0"/>
           </a:p>
         </p:txBody>
       </p:sp>
@@ -5217,7 +5217,7 @@
         </p:nvSpPr>
         <p:spPr>
           <a:xfrm>
-            <a:off x="4020176" y="3074837"/>
+            <a:off x="3825774" y="3085104"/>
             <a:ext cx="4104269" cy="1550874"/>
           </a:xfrm>
           <a:prstGeom prst="rect">
@@ -5402,7 +5402,7 @@
         </p:blipFill>
         <p:spPr>
           <a:xfrm>
-            <a:off x="6788083" y="3807974"/>
+            <a:off x="6599869" y="3839278"/>
             <a:ext cx="1426770" cy="233086"/>
           </a:xfrm>
           <a:prstGeom prst="rect">

</xml_diff>

<commit_message>
some more final editions
</commit_message>
<xml_diff>
--- a/4420 poster.pptx
+++ b/4420 poster.pptx
@@ -3807,7 +3807,7 @@
         </p:nvSpPr>
         <p:spPr>
           <a:xfrm>
-            <a:off x="301083" y="3330391"/>
+            <a:off x="293525" y="3191891"/>
             <a:ext cx="1243237" cy="276999"/>
           </a:xfrm>
           <a:prstGeom prst="rect">
@@ -3843,8 +3843,8 @@
         </p:nvSpPr>
         <p:spPr>
           <a:xfrm>
-            <a:off x="293525" y="3607390"/>
-            <a:ext cx="3270697" cy="1550874"/>
+            <a:off x="293525" y="3429000"/>
+            <a:ext cx="3503865" cy="2081788"/>
           </a:xfrm>
           <a:prstGeom prst="rect">
             <a:avLst/>
@@ -3956,6 +3956,8 @@
               <a:lnSpc>
                 <a:spcPct val="150000"/>
               </a:lnSpc>
+              <a:buFont typeface="Arial" panose="020B0604020202020204" pitchFamily="34" charset="0"/>
+              <a:buChar char="•"/>
             </a:pPr>
             <a:r>
               <a:rPr lang="en-US" altLang="zh-CN" sz="800" b="1" dirty="0"/>
@@ -3963,24 +3965,38 @@
             </a:r>
             <a:r>
               <a:rPr lang="en-US" altLang="zh-CN" sz="800" dirty="0"/>
-              <a:t> Ground elevation (</a:t>
-            </a:r>
-            <a:r>
-              <a:rPr lang="en-US" altLang="zh-CN" sz="800" dirty="0" err="1"/>
-              <a:t>ground_elv</a:t>
-            </a:r>
-            <a:r>
-              <a:rPr lang="en-US" altLang="zh-CN" sz="800" dirty="0"/>
-              <a:t>), foundation height (</a:t>
-            </a:r>
-            <a:r>
-              <a:rPr lang="en-US" altLang="zh-CN" sz="800" dirty="0" err="1"/>
-              <a:t>found_ht</a:t>
-            </a:r>
-            <a:r>
-              <a:rPr lang="en-US" altLang="zh-CN" sz="800" dirty="0"/>
-              <a:t>), structural value, year built, square footage, number of stories, building type, and foundation type.</a:t>
-            </a:r>
+              <a:t> Ground elevation, foundation height, structural value, year built, square footage, number of stories, building type, and foundation type.</a:t>
+            </a:r>
+          </a:p>
+          <a:p>
+            <a:pPr>
+              <a:lnSpc>
+                <a:spcPct val="150000"/>
+              </a:lnSpc>
+              <a:buFont typeface="Arial" panose="020B0604020202020204" pitchFamily="34" charset="0"/>
+              <a:buChar char="•"/>
+            </a:pPr>
+            <a:r>
+              <a:rPr lang="en-US" altLang="zh-CN" sz="900" b="1" dirty="0"/>
+              <a:t>Download and documentation: </a:t>
+            </a:r>
+            <a:r>
+              <a:rPr lang="en-US" altLang="zh-CN" sz="700" dirty="0">
+                <a:hlinkClick r:id="rId4"/>
+              </a:rPr>
+              <a:t>https://www.hec.usace.army.mil/confluence/nsi/technicalreferences/latest/technical-documentation</a:t>
+            </a:r>
+            <a:endParaRPr lang="en-US" altLang="zh-CN" sz="700" dirty="0"/>
+          </a:p>
+          <a:p>
+            <a:pPr>
+              <a:lnSpc>
+                <a:spcPct val="150000"/>
+              </a:lnSpc>
+              <a:buFont typeface="Arial" panose="020B0604020202020204" pitchFamily="34" charset="0"/>
+              <a:buChar char="•"/>
+            </a:pPr>
+            <a:endParaRPr lang="en-US" altLang="zh-CN" sz="800" dirty="0"/>
           </a:p>
         </p:txBody>
       </p:sp>
@@ -4248,7 +4264,7 @@
           <p:nvPr/>
         </p:nvPicPr>
         <p:blipFill>
-          <a:blip r:embed="rId4"/>
+          <a:blip r:embed="rId5"/>
           <a:stretch>
             <a:fillRect/>
           </a:stretch>
@@ -4278,7 +4294,7 @@
           <p:nvPr/>
         </p:nvPicPr>
         <p:blipFill>
-          <a:blip r:embed="rId5"/>
+          <a:blip r:embed="rId6"/>
           <a:stretch>
             <a:fillRect/>
           </a:stretch>
@@ -4526,7 +4542,7 @@
           <p:nvPr/>
         </p:nvPicPr>
         <p:blipFill>
-          <a:blip r:embed="rId6">
+          <a:blip r:embed="rId7">
             <a:extLst>
               <a:ext uri="{28A0092B-C50C-407E-A947-70E740481C1C}">
                 <a14:useLocalDpi xmlns:a14="http://schemas.microsoft.com/office/drawing/2010/main" val="0"/>
@@ -4833,7 +4849,7 @@
         </p:nvSpPr>
         <p:spPr>
           <a:xfrm>
-            <a:off x="293525" y="5217202"/>
+            <a:off x="293525" y="5309571"/>
             <a:ext cx="1243237" cy="276999"/>
           </a:xfrm>
           <a:prstGeom prst="rect">
@@ -5395,7 +5411,7 @@
           <p:nvPr/>
         </p:nvPicPr>
         <p:blipFill>
-          <a:blip r:embed="rId7"/>
+          <a:blip r:embed="rId8"/>
           <a:stretch>
             <a:fillRect/>
           </a:stretch>
@@ -5425,7 +5441,7 @@
           <p:nvPr/>
         </p:nvPicPr>
         <p:blipFill>
-          <a:blip r:embed="rId8"/>
+          <a:blip r:embed="rId9"/>
           <a:stretch>
             <a:fillRect/>
           </a:stretch>
@@ -5455,7 +5471,7 @@
           <p:nvPr/>
         </p:nvPicPr>
         <p:blipFill>
-          <a:blip r:embed="rId9"/>
+          <a:blip r:embed="rId10"/>
           <a:stretch>
             <a:fillRect/>
           </a:stretch>
@@ -5485,7 +5501,7 @@
           <p:nvPr/>
         </p:nvPicPr>
         <p:blipFill>
-          <a:blip r:embed="rId10"/>
+          <a:blip r:embed="rId11"/>
           <a:stretch>
             <a:fillRect/>
           </a:stretch>

</xml_diff>